<commit_message>
Quartz sync: Jul 2, 2025, 7:23 PM
</commit_message>
<xml_diff>
--- a/content/Articles/session32tokens.pptx
+++ b/content/Articles/session32tokens.pptx
@@ -115,7 +115,7 @@
 <file path=ppt/revisionInfo.xml><?xml version="1.0" encoding="utf-8"?>
 <p1510:revInfo xmlns:a="http://schemas.openxmlformats.org/drawingml/2006/main" xmlns:r="http://schemas.openxmlformats.org/officeDocument/2006/relationships" xmlns:p1510="http://schemas.microsoft.com/office/powerpoint/2015/10/main">
   <p1510:revLst>
-    <p1510:client id="{BBC1FA31-1213-43BB-AD77-1B1DA41181AB}" v="32" dt="2025-07-02T05:46:13.470"/>
+    <p1510:client id="{BBC1FA31-1213-43BB-AD77-1B1DA41181AB}" v="42" dt="2025-07-02T20:14:53.879"/>
   </p1510:revLst>
 </p1510:revInfo>
 </file>
@@ -125,7 +125,7 @@
   <pc:docChgLst>
     <pc:chgData name="Jack Bond" userId="d0613b4d9d68792d" providerId="LiveId" clId="{BBC1FA31-1213-43BB-AD77-1B1DA41181AB}"/>
     <pc:docChg chg="undo custSel addSld delSld modSld">
-      <pc:chgData name="Jack Bond" userId="d0613b4d9d68792d" providerId="LiveId" clId="{BBC1FA31-1213-43BB-AD77-1B1DA41181AB}" dt="2025-07-02T05:46:16.651" v="107" actId="47"/>
+      <pc:chgData name="Jack Bond" userId="d0613b4d9d68792d" providerId="LiveId" clId="{BBC1FA31-1213-43BB-AD77-1B1DA41181AB}" dt="2025-07-02T20:14:53.879" v="117" actId="1076"/>
       <pc:docMkLst>
         <pc:docMk/>
       </pc:docMkLst>
@@ -235,11 +235,19 @@
         </pc:picChg>
       </pc:sldChg>
       <pc:sldChg chg="addSp delSp modSp new mod">
-        <pc:chgData name="Jack Bond" userId="d0613b4d9d68792d" providerId="LiveId" clId="{BBC1FA31-1213-43BB-AD77-1B1DA41181AB}" dt="2025-07-02T05:46:13.468" v="106" actId="1076"/>
+        <pc:chgData name="Jack Bond" userId="d0613b4d9d68792d" providerId="LiveId" clId="{BBC1FA31-1213-43BB-AD77-1B1DA41181AB}" dt="2025-07-02T20:14:53.879" v="117" actId="1076"/>
         <pc:sldMkLst>
           <pc:docMk/>
           <pc:sldMk cId="53687160" sldId="268"/>
         </pc:sldMkLst>
+        <pc:picChg chg="add mod">
+          <ac:chgData name="Jack Bond" userId="d0613b4d9d68792d" providerId="LiveId" clId="{BBC1FA31-1213-43BB-AD77-1B1DA41181AB}" dt="2025-07-02T20:14:53.879" v="117" actId="1076"/>
+          <ac:picMkLst>
+            <pc:docMk/>
+            <pc:sldMk cId="53687160" sldId="268"/>
+            <ac:picMk id="2" creationId="{1920069B-507D-6DF0-4B57-7C4FE32801C5}"/>
+          </ac:picMkLst>
+        </pc:picChg>
         <pc:picChg chg="add del mod">
           <ac:chgData name="Jack Bond" userId="d0613b4d9d68792d" providerId="LiveId" clId="{BBC1FA31-1213-43BB-AD77-1B1DA41181AB}" dt="2025-07-02T05:45:04.501" v="87" actId="478"/>
           <ac:picMkLst>
@@ -289,7 +297,7 @@
           </ac:picMkLst>
         </pc:picChg>
         <pc:picChg chg="add mod">
-          <ac:chgData name="Jack Bond" userId="d0613b4d9d68792d" providerId="LiveId" clId="{BBC1FA31-1213-43BB-AD77-1B1DA41181AB}" dt="2025-07-02T05:46:13.468" v="106" actId="1076"/>
+          <ac:chgData name="Jack Bond" userId="d0613b4d9d68792d" providerId="LiveId" clId="{BBC1FA31-1213-43BB-AD77-1B1DA41181AB}" dt="2025-07-02T20:14:53.879" v="117" actId="1076"/>
           <ac:picMkLst>
             <pc:docMk/>
             <pc:sldMk cId="53687160" sldId="268"/>
@@ -3263,7 +3271,7 @@
         </p:blipFill>
         <p:spPr bwMode="auto">
           <a:xfrm>
-            <a:off x="1000934" y="1525137"/>
+            <a:off x="1092797" y="393284"/>
             <a:ext cx="2014415" cy="1978925"/>
           </a:xfrm>
           <a:prstGeom prst="rect">
@@ -3387,6 +3395,53 @@
           <a:prstGeom prst="rect">
             <a:avLst/>
           </a:prstGeom>
+        </p:spPr>
+      </p:pic>
+      <p:pic>
+        <p:nvPicPr>
+          <p:cNvPr id="2" name="Picture 2" descr="Wax Seal Eagle by sendorian on DeviantArt">
+            <a:extLst>
+              <a:ext uri="{FF2B5EF4-FFF2-40B4-BE49-F238E27FC236}">
+                <a16:creationId xmlns:a16="http://schemas.microsoft.com/office/drawing/2014/main" id="{1920069B-507D-6DF0-4B57-7C4FE32801C5}"/>
+              </a:ext>
+            </a:extLst>
+          </p:cNvPr>
+          <p:cNvPicPr>
+            <a:picLocks noChangeAspect="1" noChangeArrowheads="1"/>
+          </p:cNvPicPr>
+          <p:nvPr/>
+        </p:nvPicPr>
+        <p:blipFill>
+          <a:blip r:embed="rId6">
+            <a:extLst>
+              <a:ext uri="{28A0092B-C50C-407E-A947-70E740481C1C}">
+                <a14:useLocalDpi xmlns:a14="http://schemas.microsoft.com/office/drawing/2010/main" val="0"/>
+              </a:ext>
+            </a:extLst>
+          </a:blip>
+          <a:srcRect/>
+          <a:stretch>
+            <a:fillRect/>
+          </a:stretch>
+        </p:blipFill>
+        <p:spPr bwMode="auto">
+          <a:xfrm>
+            <a:off x="1092797" y="2372209"/>
+            <a:ext cx="2014415" cy="2244634"/>
+          </a:xfrm>
+          <a:prstGeom prst="rect">
+            <a:avLst/>
+          </a:prstGeom>
+          <a:noFill/>
+          <a:extLst>
+            <a:ext uri="{909E8E84-426E-40DD-AFC4-6F175D3DCCD1}">
+              <a14:hiddenFill xmlns:a14="http://schemas.microsoft.com/office/drawing/2010/main">
+                <a:solidFill>
+                  <a:srgbClr val="FFFFFF"/>
+                </a:solidFill>
+              </a14:hiddenFill>
+            </a:ext>
+          </a:extLst>
         </p:spPr>
       </p:pic>
     </p:spTree>

</xml_diff>